<commit_message>
FictionalSystems v01.04-r Added "TurnKey solution HW + SW and HW specification"
</commit_message>
<xml_diff>
--- a/docs/DocRobot_Presentation_EN.pptx
+++ b/docs/DocRobot_Presentation_EN.pptx
@@ -14,6 +14,8 @@
     <p:sldId id="262" r:id="rId13"/>
     <p:sldId id="263" r:id="rId14"/>
     <p:sldId id="264" r:id="rId15"/>
+    <p:sldId id="265" r:id="rId16"/>
+    <p:sldId id="266" r:id="rId17"/>
   </p:sldIdLst>
   <p:sldSz cx="9144000" cy="6858000" type="screen4x3"/>
   <p:notesSz cx="6858000" cy="9144000"/>
@@ -3190,6 +3192,430 @@
 </p:sld>
 </file>
 
+<file path=ppt/slides/slide10.xml><?xml version="1.0" encoding="utf-8"?>
+<p:sld xmlns:a="http://schemas.openxmlformats.org/drawingml/2006/main" xmlns:p="http://schemas.openxmlformats.org/presentationml/2006/main" xmlns:r="http://schemas.openxmlformats.org/officeDocument/2006/relationships">
+  <p:cSld>
+    <p:spTree>
+      <p:nvGrpSpPr>
+        <p:cNvPr id="1" name=""/>
+        <p:cNvGrpSpPr/>
+        <p:nvPr/>
+      </p:nvGrpSpPr>
+      <p:grpSpPr/>
+      <p:sp>
+        <p:nvSpPr>
+          <p:cNvPr id="2" name="Title 1"/>
+          <p:cNvSpPr>
+            <a:spLocks noGrp="1"/>
+          </p:cNvSpPr>
+          <p:nvPr>
+            <p:ph type="title"/>
+          </p:nvPr>
+        </p:nvSpPr>
+        <p:spPr/>
+        <p:txBody>
+          <a:bodyPr/>
+          <a:lstStyle/>
+          <a:p>
+            <a:pPr>
+              <a:defRPr sz="3200"/>
+            </a:pPr>
+            <a:r>
+              <a:t>Hardware Specifications (HW Roadmap)</a:t>
+            </a:r>
+          </a:p>
+        </p:txBody>
+      </p:sp>
+      <p:sp>
+        <p:nvSpPr>
+          <p:cNvPr id="3" name="Content Placeholder 2"/>
+          <p:cNvSpPr>
+            <a:spLocks noGrp="1"/>
+          </p:cNvSpPr>
+          <p:nvPr>
+            <p:ph idx="1"/>
+          </p:nvPr>
+        </p:nvSpPr>
+        <p:spPr/>
+        <p:txBody>
+          <a:bodyPr/>
+          <a:lstStyle/>
+          <a:p/>
+          <a:p>
+            <a:pPr>
+              <a:defRPr sz="1700"/>
+            </a:pPr>
+            <a:r>
+              <a:t>Standard (RTX 3060 12GB, 32GB RAM): For thousands of pages</a:t>
+            </a:r>
+          </a:p>
+          <a:p>
+            <a:pPr>
+              <a:defRPr sz="1700"/>
+            </a:pPr>
+            <a:r>
+              <a:t>Enterprise (RTX 4090 24GB, 64GB+ RAM): For large corporate archives</a:t>
+            </a:r>
+          </a:p>
+          <a:p>
+            <a:pPr>
+              <a:defRPr sz="1700"/>
+            </a:pPr>
+            <a:r>
+              <a:t>SSD: 1TB - 4TB NVMe for quick database retrieval</a:t>
+            </a:r>
+          </a:p>
+          <a:p>
+            <a:pPr>
+              <a:defRPr sz="1700"/>
+            </a:pPr>
+            <a:r>
+              <a:t>OS: Ubuntu 22.04 LTS (Hardened &amp; Optimized distribution)</a:t>
+            </a:r>
+          </a:p>
+          <a:p>
+            <a:pPr>
+              <a:defRPr sz="1700"/>
+            </a:pPr>
+            <a:r>
+              <a:t>NVIDIA CUDA: Full optimization for local LLM engines</a:t>
+            </a:r>
+          </a:p>
+        </p:txBody>
+      </p:sp>
+      <p:sp>
+        <p:nvSpPr>
+          <p:cNvPr id="4" name="Rectangle 3"/>
+          <p:cNvSpPr/>
+          <p:nvPr/>
+        </p:nvSpPr>
+        <p:spPr>
+          <a:xfrm>
+            <a:off x="457200" y="6446520"/>
+            <a:ext cx="8229600" cy="18288"/>
+          </a:xfrm>
+          <a:prstGeom prst="rect">
+            <a:avLst/>
+          </a:prstGeom>
+          <a:solidFill>
+            <a:srgbClr val="3498DB"/>
+          </a:solidFill>
+          <a:ln>
+            <a:noFill/>
+          </a:ln>
+        </p:spPr>
+        <p:style>
+          <a:lnRef idx="1">
+            <a:schemeClr val="accent1"/>
+          </a:lnRef>
+          <a:fillRef idx="3">
+            <a:schemeClr val="accent1"/>
+          </a:fillRef>
+          <a:effectRef idx="2">
+            <a:schemeClr val="accent1"/>
+          </a:effectRef>
+          <a:fontRef idx="minor">
+            <a:schemeClr val="lt1"/>
+          </a:fontRef>
+        </p:style>
+        <p:txBody>
+          <a:bodyPr rtlCol="0" anchor="ctr"/>
+          <a:lstStyle/>
+          <a:p>
+            <a:pPr algn="ctr"/>
+          </a:p>
+        </p:txBody>
+      </p:sp>
+      <p:sp>
+        <p:nvSpPr>
+          <p:cNvPr id="5" name="TextBox 4"/>
+          <p:cNvSpPr txBox="1"/>
+          <p:nvPr/>
+        </p:nvSpPr>
+        <p:spPr>
+          <a:xfrm>
+            <a:off x="457200" y="137160"/>
+            <a:ext cx="3657600" cy="274320"/>
+          </a:xfrm>
+          <a:prstGeom prst="rect">
+            <a:avLst/>
+          </a:prstGeom>
+          <a:noFill/>
+        </p:spPr>
+        <p:txBody>
+          <a:bodyPr wrap="none">
+            <a:spAutoFit/>
+          </a:bodyPr>
+          <a:lstStyle/>
+          <a:p>
+            <a:pPr>
+              <a:defRPr sz="1000" i="1"/>
+            </a:pPr>
+            <a:r>
+              <a:t>Fictional Systems – AI Division</a:t>
+            </a:r>
+          </a:p>
+        </p:txBody>
+      </p:sp>
+      <p:sp>
+        <p:nvSpPr>
+          <p:cNvPr id="6" name="TextBox 5"/>
+          <p:cNvSpPr txBox="1"/>
+          <p:nvPr/>
+        </p:nvSpPr>
+        <p:spPr>
+          <a:xfrm>
+            <a:off x="457200" y="6492240"/>
+            <a:ext cx="8229600" cy="365760"/>
+          </a:xfrm>
+          <a:prstGeom prst="rect">
+            <a:avLst/>
+          </a:prstGeom>
+          <a:noFill/>
+        </p:spPr>
+        <p:txBody>
+          <a:bodyPr wrap="none">
+            <a:spAutoFit/>
+          </a:bodyPr>
+          <a:lstStyle/>
+          <a:p>
+            <a:pPr algn="r">
+              <a:defRPr sz="900"/>
+            </a:pPr>
+            <a:r>
+              <a:t>DocRobot AI Solution | Confidential | © 2026 | EN</a:t>
+            </a:r>
+          </a:p>
+        </p:txBody>
+      </p:sp>
+    </p:spTree>
+  </p:cSld>
+  <p:clrMapOvr>
+    <a:masterClrMapping/>
+  </p:clrMapOvr>
+</p:sld>
+</file>
+
+<file path=ppt/slides/slide11.xml><?xml version="1.0" encoding="utf-8"?>
+<p:sld xmlns:a="http://schemas.openxmlformats.org/drawingml/2006/main" xmlns:p="http://schemas.openxmlformats.org/presentationml/2006/main" xmlns:r="http://schemas.openxmlformats.org/officeDocument/2006/relationships">
+  <p:cSld>
+    <p:spTree>
+      <p:nvGrpSpPr>
+        <p:cNvPr id="1" name=""/>
+        <p:cNvGrpSpPr/>
+        <p:nvPr/>
+      </p:nvGrpSpPr>
+      <p:grpSpPr/>
+      <p:sp>
+        <p:nvSpPr>
+          <p:cNvPr id="2" name="Title 1"/>
+          <p:cNvSpPr>
+            <a:spLocks noGrp="1"/>
+          </p:cNvSpPr>
+          <p:nvPr>
+            <p:ph type="title"/>
+          </p:nvPr>
+        </p:nvSpPr>
+        <p:spPr/>
+        <p:txBody>
+          <a:bodyPr/>
+          <a:lstStyle/>
+          <a:p>
+            <a:pPr>
+              <a:defRPr sz="3200"/>
+            </a:pPr>
+            <a:r>
+              <a:t>Get in Touch</a:t>
+            </a:r>
+          </a:p>
+        </p:txBody>
+      </p:sp>
+      <p:sp>
+        <p:nvSpPr>
+          <p:cNvPr id="3" name="Content Placeholder 2"/>
+          <p:cNvSpPr>
+            <a:spLocks noGrp="1"/>
+          </p:cNvSpPr>
+          <p:nvPr>
+            <p:ph idx="1"/>
+          </p:nvPr>
+        </p:nvSpPr>
+        <p:spPr/>
+        <p:txBody>
+          <a:bodyPr/>
+          <a:lstStyle/>
+          <a:p/>
+          <a:p>
+            <a:pPr>
+              <a:defRPr sz="1700"/>
+            </a:pPr>
+            <a:r>
+              <a:t>Fictional Systems Ltd.</a:t>
+            </a:r>
+          </a:p>
+          <a:p>
+            <a:pPr>
+              <a:defRPr sz="1700"/>
+            </a:pPr>
+            <a:r>
+              <a:t>Website: https://hrivnak.github.io/fictionalsystems/</a:t>
+            </a:r>
+          </a:p>
+          <a:p>
+            <a:pPr>
+              <a:defRPr sz="1700"/>
+            </a:pPr>
+            <a:r>
+              <a:t>Email: fictionalsystems.info@gmail.com</a:t>
+            </a:r>
+          </a:p>
+          <a:p>
+            <a:pPr>
+              <a:defRPr sz="1700"/>
+            </a:pPr>
+            <a:r>
+              <a:t>Book your initial consultation today!</a:t>
+            </a:r>
+          </a:p>
+        </p:txBody>
+      </p:sp>
+      <p:sp>
+        <p:nvSpPr>
+          <p:cNvPr id="4" name="Rectangle 3"/>
+          <p:cNvSpPr/>
+          <p:nvPr/>
+        </p:nvSpPr>
+        <p:spPr>
+          <a:xfrm>
+            <a:off x="457200" y="6446520"/>
+            <a:ext cx="8229600" cy="18288"/>
+          </a:xfrm>
+          <a:prstGeom prst="rect">
+            <a:avLst/>
+          </a:prstGeom>
+          <a:solidFill>
+            <a:srgbClr val="3498DB"/>
+          </a:solidFill>
+          <a:ln>
+            <a:noFill/>
+          </a:ln>
+        </p:spPr>
+        <p:style>
+          <a:lnRef idx="1">
+            <a:schemeClr val="accent1"/>
+          </a:lnRef>
+          <a:fillRef idx="3">
+            <a:schemeClr val="accent1"/>
+          </a:fillRef>
+          <a:effectRef idx="2">
+            <a:schemeClr val="accent1"/>
+          </a:effectRef>
+          <a:fontRef idx="minor">
+            <a:schemeClr val="lt1"/>
+          </a:fontRef>
+        </p:style>
+        <p:txBody>
+          <a:bodyPr rtlCol="0" anchor="ctr"/>
+          <a:lstStyle/>
+          <a:p>
+            <a:pPr algn="ctr"/>
+          </a:p>
+        </p:txBody>
+      </p:sp>
+      <p:pic>
+        <p:nvPicPr>
+          <p:cNvPr id="5" name="Picture 4" descr="temp_qr.png"/>
+          <p:cNvPicPr>
+            <a:picLocks noChangeAspect="1"/>
+          </p:cNvPicPr>
+          <p:nvPr/>
+        </p:nvPicPr>
+        <p:blipFill>
+          <a:blip r:embed="rId2"/>
+          <a:stretch>
+            <a:fillRect/>
+          </a:stretch>
+        </p:blipFill>
+        <p:spPr>
+          <a:xfrm>
+            <a:off x="7132320" y="4937760"/>
+            <a:ext cx="1371600" cy="1371600"/>
+          </a:xfrm>
+          <a:prstGeom prst="rect">
+            <a:avLst/>
+          </a:prstGeom>
+        </p:spPr>
+      </p:pic>
+      <p:sp>
+        <p:nvSpPr>
+          <p:cNvPr id="6" name="TextBox 5"/>
+          <p:cNvSpPr txBox="1"/>
+          <p:nvPr/>
+        </p:nvSpPr>
+        <p:spPr>
+          <a:xfrm>
+            <a:off x="457200" y="137160"/>
+            <a:ext cx="3657600" cy="274320"/>
+          </a:xfrm>
+          <a:prstGeom prst="rect">
+            <a:avLst/>
+          </a:prstGeom>
+          <a:noFill/>
+        </p:spPr>
+        <p:txBody>
+          <a:bodyPr wrap="none">
+            <a:spAutoFit/>
+          </a:bodyPr>
+          <a:lstStyle/>
+          <a:p>
+            <a:pPr>
+              <a:defRPr sz="1000" i="1"/>
+            </a:pPr>
+            <a:r>
+              <a:t>Fictional Systems – AI Division</a:t>
+            </a:r>
+          </a:p>
+        </p:txBody>
+      </p:sp>
+      <p:sp>
+        <p:nvSpPr>
+          <p:cNvPr id="7" name="TextBox 6"/>
+          <p:cNvSpPr txBox="1"/>
+          <p:nvPr/>
+        </p:nvSpPr>
+        <p:spPr>
+          <a:xfrm>
+            <a:off x="457200" y="6492240"/>
+            <a:ext cx="8229600" cy="365760"/>
+          </a:xfrm>
+          <a:prstGeom prst="rect">
+            <a:avLst/>
+          </a:prstGeom>
+          <a:noFill/>
+        </p:spPr>
+        <p:txBody>
+          <a:bodyPr wrap="none">
+            <a:spAutoFit/>
+          </a:bodyPr>
+          <a:lstStyle/>
+          <a:p>
+            <a:pPr algn="r">
+              <a:defRPr sz="900"/>
+            </a:pPr>
+            <a:r>
+              <a:t>DocRobot AI Solution | Confidential | © 2026 | EN</a:t>
+            </a:r>
+          </a:p>
+        </p:txBody>
+      </p:sp>
+    </p:spTree>
+  </p:cSld>
+  <p:clrMapOvr>
+    <a:masterClrMapping/>
+  </p:clrMapOvr>
+</p:sld>
+</file>
+
 <file path=ppt/slides/slide2.xml><?xml version="1.0" encoding="utf-8"?>
 <p:sld xmlns:a="http://schemas.openxmlformats.org/drawingml/2006/main" xmlns:p="http://schemas.openxmlformats.org/presentationml/2006/main" xmlns:r="http://schemas.openxmlformats.org/officeDocument/2006/relationships">
   <p:cSld>
@@ -4625,7 +5051,7 @@
               <a:defRPr sz="1700"/>
             </a:pPr>
             <a:r>
-              <a:t>ROI (Return on Investment) within 3 months</a:t>
+              <a:t>ROI (Return on Investment) within 6 months</a:t>
             </a:r>
           </a:p>
         </p:txBody>
@@ -4772,7 +5198,7 @@
               <a:defRPr sz="3200"/>
             </a:pPr>
             <a:r>
-              <a:t>Get in Touch</a:t>
+              <a:t>Turnkey Solution (HW + SW)</a:t>
             </a:r>
           </a:p>
         </p:txBody>
@@ -4797,7 +5223,7 @@
               <a:defRPr sz="1700"/>
             </a:pPr>
             <a:r>
-              <a:t>Fictional Systems Ltd.</a:t>
+              <a:t>Full delivery including optimized AI workstation</a:t>
             </a:r>
           </a:p>
           <a:p>
@@ -4805,7 +5231,7 @@
               <a:defRPr sz="1700"/>
             </a:pPr>
             <a:r>
-              <a:t>Website: https://hrivnak.github.io/fictionalsystems/</a:t>
+              <a:t>Fully pre-installed and configured system (Plug &amp; Play)</a:t>
             </a:r>
           </a:p>
           <a:p>
@@ -4813,7 +5239,7 @@
               <a:defRPr sz="1700"/>
             </a:pPr>
             <a:r>
-              <a:t>Email: fictionalsystems.info@gmail.com</a:t>
+              <a:t>Maximum Security: Offline operation (Air-Gapped) supported</a:t>
             </a:r>
           </a:p>
           <a:p>
@@ -4821,7 +5247,7 @@
               <a:defRPr sz="1700"/>
             </a:pPr>
             <a:r>
-              <a:t>Book your initial consultation today!</a:t>
+              <a:t>Guaranteed software compatibility with supplied hardware</a:t>
             </a:r>
           </a:p>
         </p:txBody>
@@ -4869,33 +5295,9 @@
           </a:p>
         </p:txBody>
       </p:sp>
-      <p:pic>
-        <p:nvPicPr>
-          <p:cNvPr id="5" name="Picture 4" descr="temp_qr.png"/>
-          <p:cNvPicPr>
-            <a:picLocks noChangeAspect="1"/>
-          </p:cNvPicPr>
-          <p:nvPr/>
-        </p:nvPicPr>
-        <p:blipFill>
-          <a:blip r:embed="rId2"/>
-          <a:stretch>
-            <a:fillRect/>
-          </a:stretch>
-        </p:blipFill>
-        <p:spPr>
-          <a:xfrm>
-            <a:off x="7132320" y="4937760"/>
-            <a:ext cx="1371600" cy="1371600"/>
-          </a:xfrm>
-          <a:prstGeom prst="rect">
-            <a:avLst/>
-          </a:prstGeom>
-        </p:spPr>
-      </p:pic>
-      <p:sp>
-        <p:nvSpPr>
-          <p:cNvPr id="6" name="TextBox 5"/>
+      <p:sp>
+        <p:nvSpPr>
+          <p:cNvPr id="5" name="TextBox 4"/>
           <p:cNvSpPr txBox="1"/>
           <p:nvPr/>
         </p:nvSpPr>
@@ -4926,7 +5328,7 @@
       </p:sp>
       <p:sp>
         <p:nvSpPr>
-          <p:cNvPr id="7" name="TextBox 6"/>
+          <p:cNvPr id="6" name="TextBox 5"/>
           <p:cNvSpPr txBox="1"/>
           <p:nvPr/>
         </p:nvSpPr>

</xml_diff>